<commit_message>
Update dashboard flow diagram
</commit_message>
<xml_diff>
--- a/dashboard/deploy_app/dashboard_flowchart.pptx
+++ b/dashboard/deploy_app/dashboard_flowchart.pptx
@@ -198,7 +198,7 @@
           <a:p>
             <a:fld id="{F5136626-1BC6-472E-8319-CDDADF55FDD9}" type="datetimeFigureOut">
               <a:rPr lang="en-GB" smtClean="0"/>
-              <a:t>05/02/2026</a:t>
+              <a:t>17/02/2026</a:t>
             </a:fld>
             <a:endParaRPr lang="en-GB"/>
           </a:p>
@@ -710,7 +710,7 @@
           <a:p>
             <a:fld id="{F0E58F9B-3098-426B-AD13-02A84A0CD4E4}" type="datetimeFigureOut">
               <a:rPr lang="en-GB" smtClean="0"/>
-              <a:t>05/02/2026</a:t>
+              <a:t>17/02/2026</a:t>
             </a:fld>
             <a:endParaRPr lang="en-GB"/>
           </a:p>
@@ -880,7 +880,7 @@
           <a:p>
             <a:fld id="{F0E58F9B-3098-426B-AD13-02A84A0CD4E4}" type="datetimeFigureOut">
               <a:rPr lang="en-GB" smtClean="0"/>
-              <a:t>05/02/2026</a:t>
+              <a:t>17/02/2026</a:t>
             </a:fld>
             <a:endParaRPr lang="en-GB"/>
           </a:p>
@@ -1060,7 +1060,7 @@
           <a:p>
             <a:fld id="{F0E58F9B-3098-426B-AD13-02A84A0CD4E4}" type="datetimeFigureOut">
               <a:rPr lang="en-GB" smtClean="0"/>
-              <a:t>05/02/2026</a:t>
+              <a:t>17/02/2026</a:t>
             </a:fld>
             <a:endParaRPr lang="en-GB"/>
           </a:p>
@@ -1230,7 +1230,7 @@
           <a:p>
             <a:fld id="{F0E58F9B-3098-426B-AD13-02A84A0CD4E4}" type="datetimeFigureOut">
               <a:rPr lang="en-GB" smtClean="0"/>
-              <a:t>05/02/2026</a:t>
+              <a:t>17/02/2026</a:t>
             </a:fld>
             <a:endParaRPr lang="en-GB"/>
           </a:p>
@@ -1476,7 +1476,7 @@
           <a:p>
             <a:fld id="{F0E58F9B-3098-426B-AD13-02A84A0CD4E4}" type="datetimeFigureOut">
               <a:rPr lang="en-GB" smtClean="0"/>
-              <a:t>05/02/2026</a:t>
+              <a:t>17/02/2026</a:t>
             </a:fld>
             <a:endParaRPr lang="en-GB"/>
           </a:p>
@@ -1708,7 +1708,7 @@
           <a:p>
             <a:fld id="{F0E58F9B-3098-426B-AD13-02A84A0CD4E4}" type="datetimeFigureOut">
               <a:rPr lang="en-GB" smtClean="0"/>
-              <a:t>05/02/2026</a:t>
+              <a:t>17/02/2026</a:t>
             </a:fld>
             <a:endParaRPr lang="en-GB"/>
           </a:p>
@@ -2075,7 +2075,7 @@
           <a:p>
             <a:fld id="{F0E58F9B-3098-426B-AD13-02A84A0CD4E4}" type="datetimeFigureOut">
               <a:rPr lang="en-GB" smtClean="0"/>
-              <a:t>05/02/2026</a:t>
+              <a:t>17/02/2026</a:t>
             </a:fld>
             <a:endParaRPr lang="en-GB"/>
           </a:p>
@@ -2193,7 +2193,7 @@
           <a:p>
             <a:fld id="{F0E58F9B-3098-426B-AD13-02A84A0CD4E4}" type="datetimeFigureOut">
               <a:rPr lang="en-GB" smtClean="0"/>
-              <a:t>05/02/2026</a:t>
+              <a:t>17/02/2026</a:t>
             </a:fld>
             <a:endParaRPr lang="en-GB"/>
           </a:p>
@@ -2288,7 +2288,7 @@
           <a:p>
             <a:fld id="{F0E58F9B-3098-426B-AD13-02A84A0CD4E4}" type="datetimeFigureOut">
               <a:rPr lang="en-GB" smtClean="0"/>
-              <a:t>05/02/2026</a:t>
+              <a:t>17/02/2026</a:t>
             </a:fld>
             <a:endParaRPr lang="en-GB"/>
           </a:p>
@@ -2565,7 +2565,7 @@
           <a:p>
             <a:fld id="{F0E58F9B-3098-426B-AD13-02A84A0CD4E4}" type="datetimeFigureOut">
               <a:rPr lang="en-GB" smtClean="0"/>
-              <a:t>05/02/2026</a:t>
+              <a:t>17/02/2026</a:t>
             </a:fld>
             <a:endParaRPr lang="en-GB"/>
           </a:p>
@@ -2822,7 +2822,7 @@
           <a:p>
             <a:fld id="{F0E58F9B-3098-426B-AD13-02A84A0CD4E4}" type="datetimeFigureOut">
               <a:rPr lang="en-GB" smtClean="0"/>
-              <a:t>05/02/2026</a:t>
+              <a:t>17/02/2026</a:t>
             </a:fld>
             <a:endParaRPr lang="en-GB"/>
           </a:p>
@@ -3035,7 +3035,7 @@
           <a:p>
             <a:fld id="{F0E58F9B-3098-426B-AD13-02A84A0CD4E4}" type="datetimeFigureOut">
               <a:rPr lang="en-GB" smtClean="0"/>
-              <a:t>05/02/2026</a:t>
+              <a:t>17/02/2026</a:t>
             </a:fld>
             <a:endParaRPr lang="en-GB"/>
           </a:p>
@@ -3619,53 +3619,6 @@
           </a:p>
         </p:txBody>
       </p:sp>
-      <p:cxnSp>
-        <p:nvCxnSpPr>
-          <p:cNvPr id="84" name="Straight Arrow Connector 83">
-            <a:extLst>
-              <a:ext uri="{FF2B5EF4-FFF2-40B4-BE49-F238E27FC236}">
-                <a16:creationId xmlns:a16="http://schemas.microsoft.com/office/drawing/2014/main" id="{4EF1CCDB-9502-A01E-C2C2-DE3DE96A77CB}"/>
-              </a:ext>
-            </a:extLst>
-          </p:cNvPr>
-          <p:cNvCxnSpPr>
-            <a:cxnSpLocks/>
-            <a:stCxn id="8" idx="2"/>
-            <a:endCxn id="5" idx="0"/>
-          </p:cNvCxnSpPr>
-          <p:nvPr/>
-        </p:nvCxnSpPr>
-        <p:spPr>
-          <a:xfrm>
-            <a:off x="5125453" y="5822265"/>
-            <a:ext cx="29640" cy="3254218"/>
-          </a:xfrm>
-          <a:prstGeom prst="straightConnector1">
-            <a:avLst/>
-          </a:prstGeom>
-          <a:ln w="28575">
-            <a:solidFill>
-              <a:schemeClr val="tx1"/>
-            </a:solidFill>
-            <a:headEnd type="none" w="med" len="med"/>
-            <a:tailEnd type="arrow" w="med" len="med"/>
-          </a:ln>
-        </p:spPr>
-        <p:style>
-          <a:lnRef idx="2">
-            <a:schemeClr val="accent1"/>
-          </a:lnRef>
-          <a:fillRef idx="0">
-            <a:schemeClr val="accent1"/>
-          </a:fillRef>
-          <a:effectRef idx="1">
-            <a:schemeClr val="accent1"/>
-          </a:effectRef>
-          <a:fontRef idx="minor">
-            <a:schemeClr val="tx1"/>
-          </a:fontRef>
-        </p:style>
-      </p:cxnSp>
       <p:sp>
         <p:nvSpPr>
           <p:cNvPr id="4" name="TextBox 3">
@@ -6282,53 +6235,6 @@
             <a:avLst>
               <a:gd name="adj1" fmla="val 50000"/>
             </a:avLst>
-          </a:prstGeom>
-          <a:ln w="28575">
-            <a:solidFill>
-              <a:schemeClr val="tx1"/>
-            </a:solidFill>
-            <a:headEnd type="none" w="med" len="med"/>
-            <a:tailEnd type="arrow" w="med" len="med"/>
-          </a:ln>
-        </p:spPr>
-        <p:style>
-          <a:lnRef idx="2">
-            <a:schemeClr val="accent1"/>
-          </a:lnRef>
-          <a:fillRef idx="0">
-            <a:schemeClr val="accent1"/>
-          </a:fillRef>
-          <a:effectRef idx="1">
-            <a:schemeClr val="accent1"/>
-          </a:effectRef>
-          <a:fontRef idx="minor">
-            <a:schemeClr val="tx1"/>
-          </a:fontRef>
-        </p:style>
-      </p:cxnSp>
-      <p:cxnSp>
-        <p:nvCxnSpPr>
-          <p:cNvPr id="81" name="Straight Arrow Connector 80">
-            <a:extLst>
-              <a:ext uri="{FF2B5EF4-FFF2-40B4-BE49-F238E27FC236}">
-                <a16:creationId xmlns:a16="http://schemas.microsoft.com/office/drawing/2014/main" id="{3D6C19FD-D565-27ED-2C36-046FE3CC66CC}"/>
-              </a:ext>
-            </a:extLst>
-          </p:cNvPr>
-          <p:cNvCxnSpPr>
-            <a:cxnSpLocks/>
-            <a:stCxn id="6" idx="2"/>
-            <a:endCxn id="5" idx="0"/>
-          </p:cNvCxnSpPr>
-          <p:nvPr/>
-        </p:nvCxnSpPr>
-        <p:spPr>
-          <a:xfrm>
-            <a:off x="5128275" y="8062924"/>
-            <a:ext cx="26818" cy="1013559"/>
-          </a:xfrm>
-          <a:prstGeom prst="straightConnector1">
-            <a:avLst/>
           </a:prstGeom>
           <a:ln w="28575">
             <a:solidFill>
@@ -7125,6 +7031,53 @@
             <a:ext cx="211225" cy="0"/>
           </a:xfrm>
           <a:prstGeom prst="straightConnector1">
+            <a:avLst/>
+          </a:prstGeom>
+          <a:ln w="28575">
+            <a:solidFill>
+              <a:schemeClr val="tx1"/>
+            </a:solidFill>
+            <a:headEnd type="none" w="med" len="med"/>
+            <a:tailEnd type="arrow" w="med" len="med"/>
+          </a:ln>
+        </p:spPr>
+        <p:style>
+          <a:lnRef idx="2">
+            <a:schemeClr val="accent1"/>
+          </a:lnRef>
+          <a:fillRef idx="0">
+            <a:schemeClr val="accent1"/>
+          </a:fillRef>
+          <a:effectRef idx="1">
+            <a:schemeClr val="accent1"/>
+          </a:effectRef>
+          <a:fontRef idx="minor">
+            <a:schemeClr val="tx1"/>
+          </a:fontRef>
+        </p:style>
+      </p:cxnSp>
+      <p:cxnSp>
+        <p:nvCxnSpPr>
+          <p:cNvPr id="12" name="Connector: Elbow 11">
+            <a:extLst>
+              <a:ext uri="{FF2B5EF4-FFF2-40B4-BE49-F238E27FC236}">
+                <a16:creationId xmlns:a16="http://schemas.microsoft.com/office/drawing/2014/main" id="{36FB8E1C-63DE-5EB4-FCD8-FB4651A037B9}"/>
+              </a:ext>
+            </a:extLst>
+          </p:cNvPr>
+          <p:cNvCxnSpPr>
+            <a:cxnSpLocks/>
+            <a:stCxn id="3" idx="2"/>
+            <a:endCxn id="5" idx="1"/>
+          </p:cNvCxnSpPr>
+          <p:nvPr/>
+        </p:nvCxnSpPr>
+        <p:spPr>
+          <a:xfrm rot="16200000" flipH="1">
+            <a:off x="2485832" y="7455667"/>
+            <a:ext cx="163155" cy="3621098"/>
+          </a:xfrm>
+          <a:prstGeom prst="bentConnector2">
             <a:avLst/>
           </a:prstGeom>
           <a:ln w="28575">

</xml_diff>